<commit_message>
Incorporar el logo de la UPR al poster de ACS
Logo cuadrado (900x900) colocado a escala 1:1 dentro del recuadro de
logos de la plantilla, para no deformarlo, con el espacio del logo de
ACS reservado al lado. Verificado exportando y recortando la cabecera:
entra dentro de su banda sin chocar con el titulo ni con los autores.

Co-Authored-By: Claude Opus 5 <noreply@anthropic.com>
</commit_message>
<xml_diff>
--- a/poster/acs_en/ACS_Poster_EugenIA_Lab_EN.pptx
+++ b/poster/acs_en/ACS_Poster_EugenIA_Lab_EN.pptx
@@ -3508,14 +3508,14 @@
       </p:sp>
       <p:sp>
         <p:nvSpPr>
-          <p:cNvPr id="11" name="TextBox 10"/>
+          <p:cNvPr id="12" name="TextBox 11"/>
           <p:cNvSpPr txBox="1"/>
           <p:nvPr/>
         </p:nvSpPr>
         <p:spPr>
           <a:xfrm>
-            <a:off x="28072080" y="731520"/>
-            <a:ext cx="4023360" cy="640080"/>
+            <a:off x="30038040" y="1143000"/>
+            <a:ext cx="2194560" cy="548640"/>
           </a:xfrm>
           <a:prstGeom prst="rect">
             <a:avLst/>
@@ -3523,51 +3523,25 @@
           <a:noFill/>
         </p:spPr>
         <p:txBody>
-          <a:bodyPr wrap="none">
+          <a:bodyPr wrap="square">
             <a:spAutoFit/>
           </a:bodyPr>
           <a:lstStyle/>
           <a:p>
-            <a:pPr algn="l"/>
-            <a:r>
-              <a:rPr sz="2800" b="1">
-                <a:solidFill>
-                  <a:srgbClr val="1B1B1B"/>
-                </a:solidFill>
-              </a:rPr>
-              <a:t>UPR-RP LOGO</a:t>
-            </a:r>
-          </a:p>
-        </p:txBody>
-      </p:sp>
-      <p:sp>
-        <p:nvSpPr>
-          <p:cNvPr id="12" name="TextBox 11"/>
-          <p:cNvSpPr txBox="1"/>
-          <p:nvPr/>
-        </p:nvSpPr>
-        <p:spPr>
-          <a:xfrm>
-            <a:off x="28072080" y="1371600"/>
-            <a:ext cx="4023360" cy="548640"/>
-          </a:xfrm>
-          <a:prstGeom prst="rect">
-            <a:avLst/>
-          </a:prstGeom>
-          <a:noFill/>
-        </p:spPr>
-        <p:txBody>
-          <a:bodyPr wrap="none">
-            <a:spAutoFit/>
-          </a:bodyPr>
-          <a:lstStyle/>
-          <a:p>
-            <a:pPr algn="l"/>
-            <a:r>
-              <a:rPr sz="2400" b="0">
-                <a:solidFill>
-                  <a:srgbClr val="1B1B1B"/>
-                </a:solidFill>
+            <a:pPr algn="l">
+              <a:lnSpc>
+                <a:spcPct val="92000"/>
+              </a:lnSpc>
+              <a:spcAft>
+                <a:spcPts val="0"/>
+              </a:spcAft>
+            </a:pPr>
+            <a:r>
+              <a:rPr sz="2000" b="0">
+                <a:solidFill>
+                  <a:srgbClr val="555555"/>
+                </a:solidFill>
+                <a:latin typeface="Calibri"/>
               </a:rPr>
               <a:t>ACS PR LOGO</a:t>
             </a:r>
@@ -5152,7 +5126,7 @@
       </p:sp>
       <p:pic>
         <p:nvPicPr>
-          <p:cNvPr id="49" name="Picture 48" descr="qr-produccion.png"/>
+          <p:cNvPr id="49" name="Picture 48" descr="logo_upr.jpg"/>
           <p:cNvPicPr>
             <a:picLocks noChangeAspect="1"/>
           </p:cNvPicPr>
@@ -5166,6 +5140,30 @@
         </p:blipFill>
         <p:spPr>
           <a:xfrm>
+            <a:off x="28117800" y="640080"/>
+            <a:ext cx="1737360" cy="1737360"/>
+          </a:xfrm>
+          <a:prstGeom prst="rect">
+            <a:avLst/>
+          </a:prstGeom>
+        </p:spPr>
+      </p:pic>
+      <p:pic>
+        <p:nvPicPr>
+          <p:cNvPr id="50" name="Picture 49" descr="qr-produccion.png"/>
+          <p:cNvPicPr>
+            <a:picLocks noChangeAspect="1"/>
+          </p:cNvPicPr>
+          <p:nvPr/>
+        </p:nvPicPr>
+        <p:blipFill>
+          <a:blip r:embed="rId3"/>
+          <a:stretch>
+            <a:fillRect/>
+          </a:stretch>
+        </p:blipFill>
+        <p:spPr>
+          <a:xfrm>
             <a:off x="882960" y="14324640"/>
             <a:ext cx="3080400" cy="3080400"/>
           </a:xfrm>
@@ -5176,7 +5174,7 @@
       </p:pic>
       <p:sp>
         <p:nvSpPr>
-          <p:cNvPr id="50" name="TextBox 49"/>
+          <p:cNvPr id="51" name="TextBox 50"/>
           <p:cNvSpPr txBox="1"/>
           <p:nvPr/>
         </p:nvSpPr>
@@ -5237,7 +5235,7 @@
       </p:sp>
       <p:sp>
         <p:nvSpPr>
-          <p:cNvPr id="51" name="TextBox 50"/>
+          <p:cNvPr id="52" name="TextBox 51"/>
           <p:cNvSpPr txBox="1"/>
           <p:nvPr/>
         </p:nvSpPr>
@@ -5279,7 +5277,7 @@
       </p:sp>
       <p:sp>
         <p:nvSpPr>
-          <p:cNvPr id="52" name="Rounded Rectangle 51"/>
+          <p:cNvPr id="53" name="Rounded Rectangle 52"/>
           <p:cNvSpPr/>
           <p:nvPr/>
         </p:nvSpPr>
@@ -5323,7 +5321,7 @@
       </p:sp>
       <p:sp>
         <p:nvSpPr>
-          <p:cNvPr id="53" name="TextBox 52"/>
+          <p:cNvPr id="54" name="TextBox 53"/>
           <p:cNvSpPr txBox="1"/>
           <p:nvPr/>
         </p:nvSpPr>
@@ -5365,7 +5363,7 @@
       </p:sp>
       <p:sp>
         <p:nvSpPr>
-          <p:cNvPr id="54" name="TextBox 53"/>
+          <p:cNvPr id="55" name="TextBox 54"/>
           <p:cNvSpPr txBox="1"/>
           <p:nvPr/>
         </p:nvSpPr>
@@ -5407,7 +5405,7 @@
       </p:sp>
       <p:sp>
         <p:nvSpPr>
-          <p:cNvPr id="55" name="Rounded Rectangle 54"/>
+          <p:cNvPr id="56" name="Rounded Rectangle 55"/>
           <p:cNvSpPr/>
           <p:nvPr/>
         </p:nvSpPr>
@@ -5451,7 +5449,7 @@
       </p:sp>
       <p:sp>
         <p:nvSpPr>
-          <p:cNvPr id="56" name="TextBox 55"/>
+          <p:cNvPr id="57" name="TextBox 56"/>
           <p:cNvSpPr txBox="1"/>
           <p:nvPr/>
         </p:nvSpPr>
@@ -5493,7 +5491,7 @@
       </p:sp>
       <p:sp>
         <p:nvSpPr>
-          <p:cNvPr id="57" name="TextBox 56"/>
+          <p:cNvPr id="58" name="TextBox 57"/>
           <p:cNvSpPr txBox="1"/>
           <p:nvPr/>
         </p:nvSpPr>
@@ -5535,7 +5533,7 @@
       </p:sp>
       <p:sp>
         <p:nvSpPr>
-          <p:cNvPr id="58" name="Rounded Rectangle 57"/>
+          <p:cNvPr id="59" name="Rounded Rectangle 58"/>
           <p:cNvSpPr/>
           <p:nvPr/>
         </p:nvSpPr>
@@ -5579,7 +5577,7 @@
       </p:sp>
       <p:sp>
         <p:nvSpPr>
-          <p:cNvPr id="59" name="TextBox 58"/>
+          <p:cNvPr id="60" name="TextBox 59"/>
           <p:cNvSpPr txBox="1"/>
           <p:nvPr/>
         </p:nvSpPr>
@@ -5621,7 +5619,7 @@
       </p:sp>
       <p:sp>
         <p:nvSpPr>
-          <p:cNvPr id="60" name="TextBox 59"/>
+          <p:cNvPr id="61" name="TextBox 60"/>
           <p:cNvSpPr txBox="1"/>
           <p:nvPr/>
         </p:nvSpPr>
@@ -5663,7 +5661,7 @@
       </p:sp>
       <p:sp>
         <p:nvSpPr>
-          <p:cNvPr id="61" name="Rounded Rectangle 60"/>
+          <p:cNvPr id="62" name="Rounded Rectangle 61"/>
           <p:cNvSpPr/>
           <p:nvPr/>
         </p:nvSpPr>
@@ -5707,7 +5705,7 @@
       </p:sp>
       <p:sp>
         <p:nvSpPr>
-          <p:cNvPr id="62" name="TextBox 61"/>
+          <p:cNvPr id="63" name="TextBox 62"/>
           <p:cNvSpPr txBox="1"/>
           <p:nvPr/>
         </p:nvSpPr>
@@ -5749,7 +5747,7 @@
       </p:sp>
       <p:sp>
         <p:nvSpPr>
-          <p:cNvPr id="63" name="TextBox 62"/>
+          <p:cNvPr id="64" name="TextBox 63"/>
           <p:cNvSpPr txBox="1"/>
           <p:nvPr/>
         </p:nvSpPr>
@@ -5791,7 +5789,7 @@
       </p:sp>
       <p:sp>
         <p:nvSpPr>
-          <p:cNvPr id="64" name="Rounded Rectangle 63"/>
+          <p:cNvPr id="65" name="Rounded Rectangle 64"/>
           <p:cNvSpPr/>
           <p:nvPr/>
         </p:nvSpPr>
@@ -5835,7 +5833,7 @@
       </p:sp>
       <p:sp>
         <p:nvSpPr>
-          <p:cNvPr id="65" name="TextBox 64"/>
+          <p:cNvPr id="66" name="TextBox 65"/>
           <p:cNvSpPr txBox="1"/>
           <p:nvPr/>
         </p:nvSpPr>
@@ -5877,7 +5875,7 @@
       </p:sp>
       <p:sp>
         <p:nvSpPr>
-          <p:cNvPr id="66" name="TextBox 65"/>
+          <p:cNvPr id="67" name="TextBox 66"/>
           <p:cNvSpPr txBox="1"/>
           <p:nvPr/>
         </p:nvSpPr>
@@ -5919,7 +5917,7 @@
       </p:sp>
       <p:sp>
         <p:nvSpPr>
-          <p:cNvPr id="67" name="Rounded Rectangle 66"/>
+          <p:cNvPr id="68" name="Rounded Rectangle 67"/>
           <p:cNvSpPr/>
           <p:nvPr/>
         </p:nvSpPr>
@@ -5963,7 +5961,7 @@
       </p:sp>
       <p:sp>
         <p:nvSpPr>
-          <p:cNvPr id="68" name="TextBox 67"/>
+          <p:cNvPr id="69" name="TextBox 68"/>
           <p:cNvSpPr txBox="1"/>
           <p:nvPr/>
         </p:nvSpPr>
@@ -6005,7 +6003,7 @@
       </p:sp>
       <p:sp>
         <p:nvSpPr>
-          <p:cNvPr id="69" name="TextBox 68"/>
+          <p:cNvPr id="70" name="TextBox 69"/>
           <p:cNvSpPr txBox="1"/>
           <p:nvPr/>
         </p:nvSpPr>
@@ -6047,7 +6045,7 @@
       </p:sp>
       <p:sp>
         <p:nvSpPr>
-          <p:cNvPr id="70" name="TextBox 69"/>
+          <p:cNvPr id="71" name="TextBox 70"/>
           <p:cNvSpPr txBox="1"/>
           <p:nvPr/>
         </p:nvSpPr>
@@ -6089,7 +6087,7 @@
       </p:sp>
       <p:sp>
         <p:nvSpPr>
-          <p:cNvPr id="71" name="Rounded Rectangle 70"/>
+          <p:cNvPr id="72" name="Rounded Rectangle 71"/>
           <p:cNvSpPr/>
           <p:nvPr/>
         </p:nvSpPr>
@@ -6133,7 +6131,7 @@
       </p:sp>
       <p:sp>
         <p:nvSpPr>
-          <p:cNvPr id="72" name="TextBox 71"/>
+          <p:cNvPr id="73" name="TextBox 72"/>
           <p:cNvSpPr txBox="1"/>
           <p:nvPr/>
         </p:nvSpPr>
@@ -6177,7 +6175,7 @@
       </p:sp>
       <p:sp>
         <p:nvSpPr>
-          <p:cNvPr id="73" name="TextBox 72"/>
+          <p:cNvPr id="74" name="TextBox 73"/>
           <p:cNvSpPr txBox="1"/>
           <p:nvPr/>
         </p:nvSpPr>
@@ -6219,7 +6217,7 @@
       </p:sp>
       <p:sp>
         <p:nvSpPr>
-          <p:cNvPr id="74" name="Rounded Rectangle 73"/>
+          <p:cNvPr id="75" name="Rounded Rectangle 74"/>
           <p:cNvSpPr/>
           <p:nvPr/>
         </p:nvSpPr>
@@ -6263,7 +6261,7 @@
       </p:sp>
       <p:sp>
         <p:nvSpPr>
-          <p:cNvPr id="75" name="TextBox 74"/>
+          <p:cNvPr id="76" name="TextBox 75"/>
           <p:cNvSpPr txBox="1"/>
           <p:nvPr/>
         </p:nvSpPr>
@@ -6307,7 +6305,7 @@
       </p:sp>
       <p:sp>
         <p:nvSpPr>
-          <p:cNvPr id="76" name="TextBox 75"/>
+          <p:cNvPr id="77" name="TextBox 76"/>
           <p:cNvSpPr txBox="1"/>
           <p:nvPr/>
         </p:nvSpPr>
@@ -6349,7 +6347,7 @@
       </p:sp>
       <p:sp>
         <p:nvSpPr>
-          <p:cNvPr id="77" name="Rounded Rectangle 76"/>
+          <p:cNvPr id="78" name="Rounded Rectangle 77"/>
           <p:cNvSpPr/>
           <p:nvPr/>
         </p:nvSpPr>
@@ -6393,7 +6391,7 @@
       </p:sp>
       <p:sp>
         <p:nvSpPr>
-          <p:cNvPr id="78" name="TextBox 77"/>
+          <p:cNvPr id="79" name="TextBox 78"/>
           <p:cNvSpPr txBox="1"/>
           <p:nvPr/>
         </p:nvSpPr>
@@ -6437,7 +6435,7 @@
       </p:sp>
       <p:sp>
         <p:nvSpPr>
-          <p:cNvPr id="79" name="TextBox 78"/>
+          <p:cNvPr id="80" name="TextBox 79"/>
           <p:cNvSpPr txBox="1"/>
           <p:nvPr/>
         </p:nvSpPr>
@@ -6479,7 +6477,7 @@
       </p:sp>
       <p:sp>
         <p:nvSpPr>
-          <p:cNvPr id="80" name="Rounded Rectangle 79"/>
+          <p:cNvPr id="81" name="Rounded Rectangle 80"/>
           <p:cNvSpPr/>
           <p:nvPr/>
         </p:nvSpPr>
@@ -6523,7 +6521,7 @@
       </p:sp>
       <p:sp>
         <p:nvSpPr>
-          <p:cNvPr id="81" name="TextBox 80"/>
+          <p:cNvPr id="82" name="TextBox 81"/>
           <p:cNvSpPr txBox="1"/>
           <p:nvPr/>
         </p:nvSpPr>
@@ -6566,7 +6564,7 @@
       </p:sp>
       <p:sp>
         <p:nvSpPr>
-          <p:cNvPr id="82" name="TextBox 81"/>
+          <p:cNvPr id="83" name="TextBox 82"/>
           <p:cNvSpPr txBox="1"/>
           <p:nvPr/>
         </p:nvSpPr>
@@ -6608,7 +6606,7 @@
       </p:sp>
       <p:sp>
         <p:nvSpPr>
-          <p:cNvPr id="83" name="Rounded Rectangle 82"/>
+          <p:cNvPr id="84" name="Rounded Rectangle 83"/>
           <p:cNvSpPr/>
           <p:nvPr/>
         </p:nvSpPr>
@@ -6652,7 +6650,7 @@
       </p:sp>
       <p:sp>
         <p:nvSpPr>
-          <p:cNvPr id="84" name="TextBox 83"/>
+          <p:cNvPr id="85" name="TextBox 84"/>
           <p:cNvSpPr txBox="1"/>
           <p:nvPr/>
         </p:nvSpPr>
@@ -6695,7 +6693,7 @@
       </p:sp>
       <p:sp>
         <p:nvSpPr>
-          <p:cNvPr id="85" name="TextBox 84"/>
+          <p:cNvPr id="86" name="TextBox 85"/>
           <p:cNvSpPr txBox="1"/>
           <p:nvPr/>
         </p:nvSpPr>
@@ -6737,7 +6735,7 @@
       </p:sp>
       <p:sp>
         <p:nvSpPr>
-          <p:cNvPr id="86" name="TextBox 85"/>
+          <p:cNvPr id="87" name="TextBox 86"/>
           <p:cNvSpPr txBox="1"/>
           <p:nvPr/>
         </p:nvSpPr>
@@ -6798,7 +6796,7 @@
       </p:sp>
       <p:sp>
         <p:nvSpPr>
-          <p:cNvPr id="87" name="TextBox 86"/>
+          <p:cNvPr id="88" name="TextBox 87"/>
           <p:cNvSpPr txBox="1"/>
           <p:nvPr/>
         </p:nvSpPr>
@@ -6840,7 +6838,7 @@
       </p:sp>
       <p:sp>
         <p:nvSpPr>
-          <p:cNvPr id="88" name="Rounded Rectangle 87"/>
+          <p:cNvPr id="89" name="Rounded Rectangle 88"/>
           <p:cNvSpPr/>
           <p:nvPr/>
         </p:nvSpPr>
@@ -6884,7 +6882,7 @@
       </p:sp>
       <p:sp>
         <p:nvSpPr>
-          <p:cNvPr id="89" name="TextBox 88"/>
+          <p:cNvPr id="90" name="TextBox 89"/>
           <p:cNvSpPr txBox="1"/>
           <p:nvPr/>
         </p:nvSpPr>
@@ -6938,7 +6936,7 @@
       </p:sp>
       <p:sp>
         <p:nvSpPr>
-          <p:cNvPr id="90" name="TextBox 89"/>
+          <p:cNvPr id="91" name="TextBox 90"/>
           <p:cNvSpPr txBox="1"/>
           <p:nvPr/>
         </p:nvSpPr>
@@ -6999,7 +6997,7 @@
       </p:sp>
       <p:sp>
         <p:nvSpPr>
-          <p:cNvPr id="91" name="TextBox 90"/>
+          <p:cNvPr id="92" name="TextBox 91"/>
           <p:cNvSpPr txBox="1"/>
           <p:nvPr/>
         </p:nvSpPr>
@@ -7041,7 +7039,7 @@
       </p:sp>
       <p:sp>
         <p:nvSpPr>
-          <p:cNvPr id="92" name="TextBox 91"/>
+          <p:cNvPr id="93" name="TextBox 92"/>
           <p:cNvSpPr txBox="1"/>
           <p:nvPr/>
         </p:nvSpPr>
@@ -7083,31 +7081,7 @@
       </p:sp>
       <p:pic>
         <p:nvPicPr>
-          <p:cNvPr id="93" name="Picture 92" descr="14-mde-tabla.png"/>
-          <p:cNvPicPr>
-            <a:picLocks noChangeAspect="1"/>
-          </p:cNvPicPr>
-          <p:nvPr/>
-        </p:nvPicPr>
-        <p:blipFill>
-          <a:blip r:embed="rId3"/>
-          <a:stretch>
-            <a:fillRect/>
-          </a:stretch>
-        </p:blipFill>
-        <p:spPr>
-          <a:xfrm>
-            <a:off x="19659600" y="4297680"/>
-            <a:ext cx="3886200" cy="8410135"/>
-          </a:xfrm>
-          <a:prstGeom prst="rect">
-            <a:avLst/>
-          </a:prstGeom>
-        </p:spPr>
-      </p:pic>
-      <p:pic>
-        <p:nvPicPr>
-          <p:cNvPr id="94" name="Picture 93" descr="07-busqueda-auditable.png"/>
+          <p:cNvPr id="94" name="Picture 93" descr="14-mde-tabla.png"/>
           <p:cNvPicPr>
             <a:picLocks noChangeAspect="1"/>
           </p:cNvPicPr>
@@ -7121,7 +7095,7 @@
         </p:blipFill>
         <p:spPr>
           <a:xfrm>
-            <a:off x="23865840" y="4297680"/>
+            <a:off x="19659600" y="4297680"/>
             <a:ext cx="3886200" cy="8410135"/>
           </a:xfrm>
           <a:prstGeom prst="rect">
@@ -7131,7 +7105,7 @@
       </p:pic>
       <p:pic>
         <p:nvPicPr>
-          <p:cNvPr id="95" name="Picture 94" descr="11-bibliografia-aceptadas.png"/>
+          <p:cNvPr id="95" name="Picture 94" descr="07-busqueda-auditable.png"/>
           <p:cNvPicPr>
             <a:picLocks noChangeAspect="1"/>
           </p:cNvPicPr>
@@ -7145,6 +7119,30 @@
         </p:blipFill>
         <p:spPr>
           <a:xfrm>
+            <a:off x="23865840" y="4297680"/>
+            <a:ext cx="3886200" cy="8410135"/>
+          </a:xfrm>
+          <a:prstGeom prst="rect">
+            <a:avLst/>
+          </a:prstGeom>
+        </p:spPr>
+      </p:pic>
+      <p:pic>
+        <p:nvPicPr>
+          <p:cNvPr id="96" name="Picture 95" descr="11-bibliografia-aceptadas.png"/>
+          <p:cNvPicPr>
+            <a:picLocks noChangeAspect="1"/>
+          </p:cNvPicPr>
+          <p:nvPr/>
+        </p:nvPicPr>
+        <p:blipFill>
+          <a:blip r:embed="rId6"/>
+          <a:stretch>
+            <a:fillRect/>
+          </a:stretch>
+        </p:blipFill>
+        <p:spPr>
+          <a:xfrm>
             <a:off x="28072080" y="4297680"/>
             <a:ext cx="3886200" cy="8410135"/>
           </a:xfrm>
@@ -7155,7 +7153,7 @@
       </p:pic>
       <p:sp>
         <p:nvSpPr>
-          <p:cNvPr id="96" name="TextBox 95"/>
+          <p:cNvPr id="97" name="TextBox 96"/>
           <p:cNvSpPr txBox="1"/>
           <p:nvPr/>
         </p:nvSpPr>
@@ -7235,7 +7233,7 @@
       </p:sp>
       <p:sp>
         <p:nvSpPr>
-          <p:cNvPr id="97" name="TextBox 96"/>
+          <p:cNvPr id="98" name="TextBox 97"/>
           <p:cNvSpPr txBox="1"/>
           <p:nvPr/>
         </p:nvSpPr>
@@ -7277,7 +7275,7 @@
       </p:sp>
       <p:sp>
         <p:nvSpPr>
-          <p:cNvPr id="98" name="Rounded Rectangle 97"/>
+          <p:cNvPr id="99" name="Rounded Rectangle 98"/>
           <p:cNvSpPr/>
           <p:nvPr/>
         </p:nvSpPr>
@@ -7321,7 +7319,7 @@
       </p:sp>
       <p:sp>
         <p:nvSpPr>
-          <p:cNvPr id="99" name="TextBox 98"/>
+          <p:cNvPr id="100" name="TextBox 99"/>
           <p:cNvSpPr txBox="1"/>
           <p:nvPr/>
         </p:nvSpPr>
@@ -7363,7 +7361,7 @@
       </p:sp>
       <p:sp>
         <p:nvSpPr>
-          <p:cNvPr id="100" name="TextBox 99"/>
+          <p:cNvPr id="101" name="TextBox 100"/>
           <p:cNvSpPr txBox="1"/>
           <p:nvPr/>
         </p:nvSpPr>
@@ -7405,7 +7403,7 @@
       </p:sp>
       <p:sp>
         <p:nvSpPr>
-          <p:cNvPr id="101" name="TextBox 100"/>
+          <p:cNvPr id="102" name="TextBox 101"/>
           <p:cNvSpPr txBox="1"/>
           <p:nvPr/>
         </p:nvSpPr>

</xml_diff>

<commit_message>
Anadir los tres logos institucionales al poster de ACS
UPR, Colegio de Quimicos de Puerto Rico y ACS Puerto Rico, alineados a la
misma altura y cada uno conservando su proporcion: los dos primeros son
cuadrados y el de ACS es vertical (0.566 ancho/alto), asi que igualarlos
por ancho los habria deformado.

Dos archivos hubo que prepararlos. El de ACS venia en .webp, que
PowerPoint no maneja de forma fiable, y se convirtio a PNG. El del
Colegio traia un 12.5% de margen transparente por lado (solo el 56% de su
area era contenido) y se recorto: sin eso se veia visiblemente mas
pequeno que los otros dos aunque estuviera a la misma altura nominal.

Verificado exportando la cabecera y recortando la zona de logos.

Co-Authored-By: Claude Opus 5 <noreply@anthropic.com>
</commit_message>
<xml_diff>
--- a/poster/acs_en/ACS_Poster_EugenIA_Lab_EN.pptx
+++ b/poster/acs_en/ACS_Poster_EugenIA_Lab_EN.pptx
@@ -3469,8 +3469,8 @@
         </p:nvSpPr>
         <p:spPr>
           <a:xfrm>
-            <a:off x="27889200" y="457200"/>
-            <a:ext cx="4389120" cy="2103120"/>
+            <a:off x="27077487" y="301752"/>
+            <a:ext cx="5372465" cy="2066543"/>
           </a:xfrm>
           <a:prstGeom prst="rect">
             <a:avLst/>
@@ -3508,48 +3508,6 @@
       </p:sp>
       <p:sp>
         <p:nvSpPr>
-          <p:cNvPr id="12" name="TextBox 11"/>
-          <p:cNvSpPr txBox="1"/>
-          <p:nvPr/>
-        </p:nvSpPr>
-        <p:spPr>
-          <a:xfrm>
-            <a:off x="30038040" y="1143000"/>
-            <a:ext cx="2194560" cy="548640"/>
-          </a:xfrm>
-          <a:prstGeom prst="rect">
-            <a:avLst/>
-          </a:prstGeom>
-          <a:noFill/>
-        </p:spPr>
-        <p:txBody>
-          <a:bodyPr wrap="square">
-            <a:spAutoFit/>
-          </a:bodyPr>
-          <a:lstStyle/>
-          <a:p>
-            <a:pPr algn="l">
-              <a:lnSpc>
-                <a:spcPct val="92000"/>
-              </a:lnSpc>
-              <a:spcAft>
-                <a:spcPts val="0"/>
-              </a:spcAft>
-            </a:pPr>
-            <a:r>
-              <a:rPr sz="2000" b="0">
-                <a:solidFill>
-                  <a:srgbClr val="555555"/>
-                </a:solidFill>
-                <a:latin typeface="Calibri"/>
-              </a:rPr>
-              <a:t>ACS PR LOGO</a:t>
-            </a:r>
-          </a:p>
-        </p:txBody>
-      </p:sp>
-      <p:sp>
-        <p:nvSpPr>
           <p:cNvPr id="13" name="TextBox 12"/>
           <p:cNvSpPr txBox="1"/>
           <p:nvPr/>
@@ -5140,7 +5098,7 @@
         </p:blipFill>
         <p:spPr>
           <a:xfrm>
-            <a:off x="28117800" y="640080"/>
+            <a:off x="27333519" y="466344"/>
             <a:ext cx="1737360" cy="1737360"/>
           </a:xfrm>
           <a:prstGeom prst="rect">
@@ -5150,7 +5108,7 @@
       </p:pic>
       <p:pic>
         <p:nvPicPr>
-          <p:cNvPr id="50" name="Picture 49" descr="qr-produccion.png"/>
+          <p:cNvPr id="50" name="Picture 49" descr="logo_colegio_rec.png"/>
           <p:cNvPicPr>
             <a:picLocks noChangeAspect="1"/>
           </p:cNvPicPr>
@@ -5164,6 +5122,54 @@
         </p:blipFill>
         <p:spPr>
           <a:xfrm>
+            <a:off x="29272047" y="466344"/>
+            <a:ext cx="1737360" cy="1737360"/>
+          </a:xfrm>
+          <a:prstGeom prst="rect">
+            <a:avLst/>
+          </a:prstGeom>
+        </p:spPr>
+      </p:pic>
+      <p:pic>
+        <p:nvPicPr>
+          <p:cNvPr id="51" name="Picture 50" descr="logo_acs.png"/>
+          <p:cNvPicPr>
+            <a:picLocks noChangeAspect="1"/>
+          </p:cNvPicPr>
+          <p:nvPr/>
+        </p:nvPicPr>
+        <p:blipFill>
+          <a:blip r:embed="rId4"/>
+          <a:stretch>
+            <a:fillRect/>
+          </a:stretch>
+        </p:blipFill>
+        <p:spPr>
+          <a:xfrm>
+            <a:off x="31210575" y="466344"/>
+            <a:ext cx="983345" cy="1737360"/>
+          </a:xfrm>
+          <a:prstGeom prst="rect">
+            <a:avLst/>
+          </a:prstGeom>
+        </p:spPr>
+      </p:pic>
+      <p:pic>
+        <p:nvPicPr>
+          <p:cNvPr id="52" name="Picture 51" descr="qr-produccion.png"/>
+          <p:cNvPicPr>
+            <a:picLocks noChangeAspect="1"/>
+          </p:cNvPicPr>
+          <p:nvPr/>
+        </p:nvPicPr>
+        <p:blipFill>
+          <a:blip r:embed="rId5"/>
+          <a:stretch>
+            <a:fillRect/>
+          </a:stretch>
+        </p:blipFill>
+        <p:spPr>
+          <a:xfrm>
             <a:off x="882960" y="14324640"/>
             <a:ext cx="3080400" cy="3080400"/>
           </a:xfrm>
@@ -5174,7 +5180,7 @@
       </p:pic>
       <p:sp>
         <p:nvSpPr>
-          <p:cNvPr id="51" name="TextBox 50"/>
+          <p:cNvPr id="53" name="TextBox 52"/>
           <p:cNvSpPr txBox="1"/>
           <p:nvPr/>
         </p:nvSpPr>
@@ -5235,7 +5241,7 @@
       </p:sp>
       <p:sp>
         <p:nvSpPr>
-          <p:cNvPr id="52" name="TextBox 51"/>
+          <p:cNvPr id="54" name="TextBox 53"/>
           <p:cNvSpPr txBox="1"/>
           <p:nvPr/>
         </p:nvSpPr>
@@ -5277,7 +5283,7 @@
       </p:sp>
       <p:sp>
         <p:nvSpPr>
-          <p:cNvPr id="53" name="Rounded Rectangle 52"/>
+          <p:cNvPr id="55" name="Rounded Rectangle 54"/>
           <p:cNvSpPr/>
           <p:nvPr/>
         </p:nvSpPr>
@@ -5321,7 +5327,7 @@
       </p:sp>
       <p:sp>
         <p:nvSpPr>
-          <p:cNvPr id="54" name="TextBox 53"/>
+          <p:cNvPr id="56" name="TextBox 55"/>
           <p:cNvSpPr txBox="1"/>
           <p:nvPr/>
         </p:nvSpPr>
@@ -5363,7 +5369,7 @@
       </p:sp>
       <p:sp>
         <p:nvSpPr>
-          <p:cNvPr id="55" name="TextBox 54"/>
+          <p:cNvPr id="57" name="TextBox 56"/>
           <p:cNvSpPr txBox="1"/>
           <p:nvPr/>
         </p:nvSpPr>
@@ -5405,7 +5411,7 @@
       </p:sp>
       <p:sp>
         <p:nvSpPr>
-          <p:cNvPr id="56" name="Rounded Rectangle 55"/>
+          <p:cNvPr id="58" name="Rounded Rectangle 57"/>
           <p:cNvSpPr/>
           <p:nvPr/>
         </p:nvSpPr>
@@ -5449,7 +5455,7 @@
       </p:sp>
       <p:sp>
         <p:nvSpPr>
-          <p:cNvPr id="57" name="TextBox 56"/>
+          <p:cNvPr id="59" name="TextBox 58"/>
           <p:cNvSpPr txBox="1"/>
           <p:nvPr/>
         </p:nvSpPr>
@@ -5491,7 +5497,7 @@
       </p:sp>
       <p:sp>
         <p:nvSpPr>
-          <p:cNvPr id="58" name="TextBox 57"/>
+          <p:cNvPr id="60" name="TextBox 59"/>
           <p:cNvSpPr txBox="1"/>
           <p:nvPr/>
         </p:nvSpPr>
@@ -5533,7 +5539,7 @@
       </p:sp>
       <p:sp>
         <p:nvSpPr>
-          <p:cNvPr id="59" name="Rounded Rectangle 58"/>
+          <p:cNvPr id="61" name="Rounded Rectangle 60"/>
           <p:cNvSpPr/>
           <p:nvPr/>
         </p:nvSpPr>
@@ -5577,7 +5583,7 @@
       </p:sp>
       <p:sp>
         <p:nvSpPr>
-          <p:cNvPr id="60" name="TextBox 59"/>
+          <p:cNvPr id="62" name="TextBox 61"/>
           <p:cNvSpPr txBox="1"/>
           <p:nvPr/>
         </p:nvSpPr>
@@ -5619,7 +5625,7 @@
       </p:sp>
       <p:sp>
         <p:nvSpPr>
-          <p:cNvPr id="61" name="TextBox 60"/>
+          <p:cNvPr id="63" name="TextBox 62"/>
           <p:cNvSpPr txBox="1"/>
           <p:nvPr/>
         </p:nvSpPr>
@@ -5661,7 +5667,7 @@
       </p:sp>
       <p:sp>
         <p:nvSpPr>
-          <p:cNvPr id="62" name="Rounded Rectangle 61"/>
+          <p:cNvPr id="64" name="Rounded Rectangle 63"/>
           <p:cNvSpPr/>
           <p:nvPr/>
         </p:nvSpPr>
@@ -5705,7 +5711,7 @@
       </p:sp>
       <p:sp>
         <p:nvSpPr>
-          <p:cNvPr id="63" name="TextBox 62"/>
+          <p:cNvPr id="65" name="TextBox 64"/>
           <p:cNvSpPr txBox="1"/>
           <p:nvPr/>
         </p:nvSpPr>
@@ -5747,7 +5753,7 @@
       </p:sp>
       <p:sp>
         <p:nvSpPr>
-          <p:cNvPr id="64" name="TextBox 63"/>
+          <p:cNvPr id="66" name="TextBox 65"/>
           <p:cNvSpPr txBox="1"/>
           <p:nvPr/>
         </p:nvSpPr>
@@ -5789,7 +5795,7 @@
       </p:sp>
       <p:sp>
         <p:nvSpPr>
-          <p:cNvPr id="65" name="Rounded Rectangle 64"/>
+          <p:cNvPr id="67" name="Rounded Rectangle 66"/>
           <p:cNvSpPr/>
           <p:nvPr/>
         </p:nvSpPr>
@@ -5833,7 +5839,7 @@
       </p:sp>
       <p:sp>
         <p:nvSpPr>
-          <p:cNvPr id="66" name="TextBox 65"/>
+          <p:cNvPr id="68" name="TextBox 67"/>
           <p:cNvSpPr txBox="1"/>
           <p:nvPr/>
         </p:nvSpPr>
@@ -5875,7 +5881,7 @@
       </p:sp>
       <p:sp>
         <p:nvSpPr>
-          <p:cNvPr id="67" name="TextBox 66"/>
+          <p:cNvPr id="69" name="TextBox 68"/>
           <p:cNvSpPr txBox="1"/>
           <p:nvPr/>
         </p:nvSpPr>
@@ -5917,7 +5923,7 @@
       </p:sp>
       <p:sp>
         <p:nvSpPr>
-          <p:cNvPr id="68" name="Rounded Rectangle 67"/>
+          <p:cNvPr id="70" name="Rounded Rectangle 69"/>
           <p:cNvSpPr/>
           <p:nvPr/>
         </p:nvSpPr>
@@ -5961,7 +5967,7 @@
       </p:sp>
       <p:sp>
         <p:nvSpPr>
-          <p:cNvPr id="69" name="TextBox 68"/>
+          <p:cNvPr id="71" name="TextBox 70"/>
           <p:cNvSpPr txBox="1"/>
           <p:nvPr/>
         </p:nvSpPr>
@@ -6003,7 +6009,7 @@
       </p:sp>
       <p:sp>
         <p:nvSpPr>
-          <p:cNvPr id="70" name="TextBox 69"/>
+          <p:cNvPr id="72" name="TextBox 71"/>
           <p:cNvSpPr txBox="1"/>
           <p:nvPr/>
         </p:nvSpPr>
@@ -6045,7 +6051,7 @@
       </p:sp>
       <p:sp>
         <p:nvSpPr>
-          <p:cNvPr id="71" name="TextBox 70"/>
+          <p:cNvPr id="73" name="TextBox 72"/>
           <p:cNvSpPr txBox="1"/>
           <p:nvPr/>
         </p:nvSpPr>
@@ -6087,7 +6093,7 @@
       </p:sp>
       <p:sp>
         <p:nvSpPr>
-          <p:cNvPr id="72" name="Rounded Rectangle 71"/>
+          <p:cNvPr id="74" name="Rounded Rectangle 73"/>
           <p:cNvSpPr/>
           <p:nvPr/>
         </p:nvSpPr>
@@ -6131,7 +6137,7 @@
       </p:sp>
       <p:sp>
         <p:nvSpPr>
-          <p:cNvPr id="73" name="TextBox 72"/>
+          <p:cNvPr id="75" name="TextBox 74"/>
           <p:cNvSpPr txBox="1"/>
           <p:nvPr/>
         </p:nvSpPr>
@@ -6175,7 +6181,7 @@
       </p:sp>
       <p:sp>
         <p:nvSpPr>
-          <p:cNvPr id="74" name="TextBox 73"/>
+          <p:cNvPr id="76" name="TextBox 75"/>
           <p:cNvSpPr txBox="1"/>
           <p:nvPr/>
         </p:nvSpPr>
@@ -6217,7 +6223,7 @@
       </p:sp>
       <p:sp>
         <p:nvSpPr>
-          <p:cNvPr id="75" name="Rounded Rectangle 74"/>
+          <p:cNvPr id="77" name="Rounded Rectangle 76"/>
           <p:cNvSpPr/>
           <p:nvPr/>
         </p:nvSpPr>
@@ -6261,7 +6267,7 @@
       </p:sp>
       <p:sp>
         <p:nvSpPr>
-          <p:cNvPr id="76" name="TextBox 75"/>
+          <p:cNvPr id="78" name="TextBox 77"/>
           <p:cNvSpPr txBox="1"/>
           <p:nvPr/>
         </p:nvSpPr>
@@ -6305,7 +6311,7 @@
       </p:sp>
       <p:sp>
         <p:nvSpPr>
-          <p:cNvPr id="77" name="TextBox 76"/>
+          <p:cNvPr id="79" name="TextBox 78"/>
           <p:cNvSpPr txBox="1"/>
           <p:nvPr/>
         </p:nvSpPr>
@@ -6347,7 +6353,7 @@
       </p:sp>
       <p:sp>
         <p:nvSpPr>
-          <p:cNvPr id="78" name="Rounded Rectangle 77"/>
+          <p:cNvPr id="80" name="Rounded Rectangle 79"/>
           <p:cNvSpPr/>
           <p:nvPr/>
         </p:nvSpPr>
@@ -6391,7 +6397,7 @@
       </p:sp>
       <p:sp>
         <p:nvSpPr>
-          <p:cNvPr id="79" name="TextBox 78"/>
+          <p:cNvPr id="81" name="TextBox 80"/>
           <p:cNvSpPr txBox="1"/>
           <p:nvPr/>
         </p:nvSpPr>
@@ -6435,7 +6441,7 @@
       </p:sp>
       <p:sp>
         <p:nvSpPr>
-          <p:cNvPr id="80" name="TextBox 79"/>
+          <p:cNvPr id="82" name="TextBox 81"/>
           <p:cNvSpPr txBox="1"/>
           <p:nvPr/>
         </p:nvSpPr>
@@ -6477,7 +6483,7 @@
       </p:sp>
       <p:sp>
         <p:nvSpPr>
-          <p:cNvPr id="81" name="Rounded Rectangle 80"/>
+          <p:cNvPr id="83" name="Rounded Rectangle 82"/>
           <p:cNvSpPr/>
           <p:nvPr/>
         </p:nvSpPr>
@@ -6521,7 +6527,7 @@
       </p:sp>
       <p:sp>
         <p:nvSpPr>
-          <p:cNvPr id="82" name="TextBox 81"/>
+          <p:cNvPr id="84" name="TextBox 83"/>
           <p:cNvSpPr txBox="1"/>
           <p:nvPr/>
         </p:nvSpPr>
@@ -6564,7 +6570,7 @@
       </p:sp>
       <p:sp>
         <p:nvSpPr>
-          <p:cNvPr id="83" name="TextBox 82"/>
+          <p:cNvPr id="85" name="TextBox 84"/>
           <p:cNvSpPr txBox="1"/>
           <p:nvPr/>
         </p:nvSpPr>
@@ -6606,7 +6612,7 @@
       </p:sp>
       <p:sp>
         <p:nvSpPr>
-          <p:cNvPr id="84" name="Rounded Rectangle 83"/>
+          <p:cNvPr id="86" name="Rounded Rectangle 85"/>
           <p:cNvSpPr/>
           <p:nvPr/>
         </p:nvSpPr>
@@ -6650,7 +6656,7 @@
       </p:sp>
       <p:sp>
         <p:nvSpPr>
-          <p:cNvPr id="85" name="TextBox 84"/>
+          <p:cNvPr id="87" name="TextBox 86"/>
           <p:cNvSpPr txBox="1"/>
           <p:nvPr/>
         </p:nvSpPr>
@@ -6693,7 +6699,7 @@
       </p:sp>
       <p:sp>
         <p:nvSpPr>
-          <p:cNvPr id="86" name="TextBox 85"/>
+          <p:cNvPr id="88" name="TextBox 87"/>
           <p:cNvSpPr txBox="1"/>
           <p:nvPr/>
         </p:nvSpPr>
@@ -6735,7 +6741,7 @@
       </p:sp>
       <p:sp>
         <p:nvSpPr>
-          <p:cNvPr id="87" name="TextBox 86"/>
+          <p:cNvPr id="89" name="TextBox 88"/>
           <p:cNvSpPr txBox="1"/>
           <p:nvPr/>
         </p:nvSpPr>
@@ -6796,7 +6802,7 @@
       </p:sp>
       <p:sp>
         <p:nvSpPr>
-          <p:cNvPr id="88" name="TextBox 87"/>
+          <p:cNvPr id="90" name="TextBox 89"/>
           <p:cNvSpPr txBox="1"/>
           <p:nvPr/>
         </p:nvSpPr>
@@ -6838,7 +6844,7 @@
       </p:sp>
       <p:sp>
         <p:nvSpPr>
-          <p:cNvPr id="89" name="Rounded Rectangle 88"/>
+          <p:cNvPr id="91" name="Rounded Rectangle 90"/>
           <p:cNvSpPr/>
           <p:nvPr/>
         </p:nvSpPr>
@@ -6882,7 +6888,7 @@
       </p:sp>
       <p:sp>
         <p:nvSpPr>
-          <p:cNvPr id="90" name="TextBox 89"/>
+          <p:cNvPr id="92" name="TextBox 91"/>
           <p:cNvSpPr txBox="1"/>
           <p:nvPr/>
         </p:nvSpPr>
@@ -6936,7 +6942,7 @@
       </p:sp>
       <p:sp>
         <p:nvSpPr>
-          <p:cNvPr id="91" name="TextBox 90"/>
+          <p:cNvPr id="93" name="TextBox 92"/>
           <p:cNvSpPr txBox="1"/>
           <p:nvPr/>
         </p:nvSpPr>
@@ -6997,7 +7003,7 @@
       </p:sp>
       <p:sp>
         <p:nvSpPr>
-          <p:cNvPr id="92" name="TextBox 91"/>
+          <p:cNvPr id="94" name="TextBox 93"/>
           <p:cNvSpPr txBox="1"/>
           <p:nvPr/>
         </p:nvSpPr>
@@ -7039,7 +7045,7 @@
       </p:sp>
       <p:sp>
         <p:nvSpPr>
-          <p:cNvPr id="93" name="TextBox 92"/>
+          <p:cNvPr id="95" name="TextBox 94"/>
           <p:cNvSpPr txBox="1"/>
           <p:nvPr/>
         </p:nvSpPr>
@@ -7081,55 +7087,7 @@
       </p:sp>
       <p:pic>
         <p:nvPicPr>
-          <p:cNvPr id="94" name="Picture 93" descr="14-mde-tabla.png"/>
-          <p:cNvPicPr>
-            <a:picLocks noChangeAspect="1"/>
-          </p:cNvPicPr>
-          <p:nvPr/>
-        </p:nvPicPr>
-        <p:blipFill>
-          <a:blip r:embed="rId4"/>
-          <a:stretch>
-            <a:fillRect/>
-          </a:stretch>
-        </p:blipFill>
-        <p:spPr>
-          <a:xfrm>
-            <a:off x="19659600" y="4297680"/>
-            <a:ext cx="3886200" cy="8410135"/>
-          </a:xfrm>
-          <a:prstGeom prst="rect">
-            <a:avLst/>
-          </a:prstGeom>
-        </p:spPr>
-      </p:pic>
-      <p:pic>
-        <p:nvPicPr>
-          <p:cNvPr id="95" name="Picture 94" descr="07-busqueda-auditable.png"/>
-          <p:cNvPicPr>
-            <a:picLocks noChangeAspect="1"/>
-          </p:cNvPicPr>
-          <p:nvPr/>
-        </p:nvPicPr>
-        <p:blipFill>
-          <a:blip r:embed="rId5"/>
-          <a:stretch>
-            <a:fillRect/>
-          </a:stretch>
-        </p:blipFill>
-        <p:spPr>
-          <a:xfrm>
-            <a:off x="23865840" y="4297680"/>
-            <a:ext cx="3886200" cy="8410135"/>
-          </a:xfrm>
-          <a:prstGeom prst="rect">
-            <a:avLst/>
-          </a:prstGeom>
-        </p:spPr>
-      </p:pic>
-      <p:pic>
-        <p:nvPicPr>
-          <p:cNvPr id="96" name="Picture 95" descr="11-bibliografia-aceptadas.png"/>
+          <p:cNvPr id="96" name="Picture 95" descr="14-mde-tabla.png"/>
           <p:cNvPicPr>
             <a:picLocks noChangeAspect="1"/>
           </p:cNvPicPr>
@@ -7143,6 +7101,54 @@
         </p:blipFill>
         <p:spPr>
           <a:xfrm>
+            <a:off x="19659600" y="4297680"/>
+            <a:ext cx="3886200" cy="8410135"/>
+          </a:xfrm>
+          <a:prstGeom prst="rect">
+            <a:avLst/>
+          </a:prstGeom>
+        </p:spPr>
+      </p:pic>
+      <p:pic>
+        <p:nvPicPr>
+          <p:cNvPr id="97" name="Picture 96" descr="07-busqueda-auditable.png"/>
+          <p:cNvPicPr>
+            <a:picLocks noChangeAspect="1"/>
+          </p:cNvPicPr>
+          <p:nvPr/>
+        </p:nvPicPr>
+        <p:blipFill>
+          <a:blip r:embed="rId7"/>
+          <a:stretch>
+            <a:fillRect/>
+          </a:stretch>
+        </p:blipFill>
+        <p:spPr>
+          <a:xfrm>
+            <a:off x="23865840" y="4297680"/>
+            <a:ext cx="3886200" cy="8410135"/>
+          </a:xfrm>
+          <a:prstGeom prst="rect">
+            <a:avLst/>
+          </a:prstGeom>
+        </p:spPr>
+      </p:pic>
+      <p:pic>
+        <p:nvPicPr>
+          <p:cNvPr id="98" name="Picture 97" descr="11-bibliografia-aceptadas.png"/>
+          <p:cNvPicPr>
+            <a:picLocks noChangeAspect="1"/>
+          </p:cNvPicPr>
+          <p:nvPr/>
+        </p:nvPicPr>
+        <p:blipFill>
+          <a:blip r:embed="rId8"/>
+          <a:stretch>
+            <a:fillRect/>
+          </a:stretch>
+        </p:blipFill>
+        <p:spPr>
+          <a:xfrm>
             <a:off x="28072080" y="4297680"/>
             <a:ext cx="3886200" cy="8410135"/>
           </a:xfrm>
@@ -7153,7 +7159,7 @@
       </p:pic>
       <p:sp>
         <p:nvSpPr>
-          <p:cNvPr id="97" name="TextBox 96"/>
+          <p:cNvPr id="99" name="TextBox 98"/>
           <p:cNvSpPr txBox="1"/>
           <p:nvPr/>
         </p:nvSpPr>
@@ -7233,7 +7239,7 @@
       </p:sp>
       <p:sp>
         <p:nvSpPr>
-          <p:cNvPr id="98" name="TextBox 97"/>
+          <p:cNvPr id="100" name="TextBox 99"/>
           <p:cNvSpPr txBox="1"/>
           <p:nvPr/>
         </p:nvSpPr>
@@ -7275,7 +7281,7 @@
       </p:sp>
       <p:sp>
         <p:nvSpPr>
-          <p:cNvPr id="99" name="Rounded Rectangle 98"/>
+          <p:cNvPr id="101" name="Rounded Rectangle 100"/>
           <p:cNvSpPr/>
           <p:nvPr/>
         </p:nvSpPr>
@@ -7319,7 +7325,7 @@
       </p:sp>
       <p:sp>
         <p:nvSpPr>
-          <p:cNvPr id="100" name="TextBox 99"/>
+          <p:cNvPr id="102" name="TextBox 101"/>
           <p:cNvSpPr txBox="1"/>
           <p:nvPr/>
         </p:nvSpPr>
@@ -7361,7 +7367,7 @@
       </p:sp>
       <p:sp>
         <p:nvSpPr>
-          <p:cNvPr id="101" name="TextBox 100"/>
+          <p:cNvPr id="103" name="TextBox 102"/>
           <p:cNvSpPr txBox="1"/>
           <p:nvPr/>
         </p:nvSpPr>
@@ -7403,7 +7409,7 @@
       </p:sp>
       <p:sp>
         <p:nvSpPr>
-          <p:cNvPr id="102" name="TextBox 101"/>
+          <p:cNvPr id="104" name="TextBox 103"/>
           <p:cNvSpPr txBox="1"/>
           <p:nvPr/>
         </p:nvSpPr>

</xml_diff>